<commit_message>
Swap unrealistic call-center columns for survey-native categorical fields
handle_time_seconds / is_first_contact_resolution / is_repeat_contact_30d
live in a separate telephony/CRM system and would need a real operational
join - not something a CSAT survey table itself would realistically carry.
Replaced with plan_tier, circle, and survey_type: all genuine customer-
master / survey-platform attributes routinely pre-joined onto a survey
export by customer ID, no cross-system operational join implied.

Updated summary/chart sections, PPT deck content, narration numbers, and
CLAUDE.md's decision log to match. Regenerated and reverified end-to-end.
</commit_message>
<xml_diff>
--- a/usecase1_csat_nlp_rootcause/final_output/usecase1_csat_summary.pptx
+++ b/usecase1_csat_nlp_rootcause/final_output/usecase1_csat_summary.pptx
@@ -3738,7 +3738,7 @@
                 </a:solidFill>
                 <a:latin typeface="Calibri"/>
               </a:rPr>
-              <a:t>Channel mix:  Voice: 3,319  |  Chat: 2,711  |  Email: 1,470</a:t>
+              <a:t>Channel mix:  Voice: 3,350  |  Chat: 2,642  |  Email: 1,508</a:t>
             </a:r>
           </a:p>
         </p:txBody>
@@ -4246,7 +4246,7 @@
                 </a:solidFill>
                 <a:latin typeface="Calibri"/>
               </a:rPr>
-              <a:t>33%</a:t>
+              <a:t>32%</a:t>
             </a:r>
           </a:p>
           <a:p>
@@ -4313,7 +4313,7 @@
                 </a:solidFill>
                 <a:latin typeface="Calibri"/>
               </a:rPr>
-              <a:t>3.00</a:t>
+              <a:t>3.01</a:t>
             </a:r>
           </a:p>
           <a:p>
@@ -4380,7 +4380,7 @@
                 </a:solidFill>
                 <a:latin typeface="Calibri"/>
               </a:rPr>
-              <a:t>51%</a:t>
+              <a:t>50%</a:t>
             </a:r>
           </a:p>
           <a:p>
@@ -4447,7 +4447,7 @@
                 </a:solidFill>
                 <a:latin typeface="Calibri"/>
               </a:rPr>
-              <a:t>55%</a:t>
+              <a:t>2.96</a:t>
             </a:r>
           </a:p>
           <a:p>
@@ -4459,7 +4459,7 @@
                 </a:solidFill>
                 <a:latin typeface="Calibri"/>
               </a:rPr>
-              <a:t>First-Contact Resolution rate for Billing Charges</a:t>
+              <a:t>Lowest avg CSAT: Delhi NCR circle</a:t>
             </a:r>
           </a:p>
         </p:txBody>
@@ -4498,7 +4498,7 @@
                 </a:solidFill>
                 <a:latin typeface="Calibri"/>
               </a:rPr>
-              <a:t>●   Billing Charges is both the highest-VOLUME and lowest-CSAT driver (avg CSAT 2.48) - the clear priority-one fix.</a:t>
+              <a:t>●   Billing Charges is both the highest-VOLUME and lowest-CSAT driver (avg CSAT 2.50) - the clear priority-one fix.</a:t>
             </a:r>
           </a:p>
           <a:p>
@@ -4514,7 +4514,7 @@
                 </a:solidFill>
                 <a:latin typeface="Calibri"/>
               </a:rPr>
-              <a:t>●   It also runs the longest average handle time (493 seconds) - a real operational cost on top of the CSAT hit.</a:t>
+              <a:t>●   Delhi NCR is the lowest-performing circle (avg CSAT 2.96) and Postpaid Standard the lowest-performing plan tier (avg CSAT 2.90) - two segment-level leads worth investigating alongside the process fix.</a:t>
             </a:r>
           </a:p>
           <a:p>
@@ -4681,7 +4681,7 @@
                 </a:solidFill>
                 <a:latin typeface="Calibri"/>
               </a:rPr>
-              <a:t>●   Fix #1: Billing Charges - the single biggest, lowest-scoring driver, concentrated and compounding with “Sub-theme: Roaming Add” in 71% of its own complaints.</a:t>
+              <a:t>●   Fix #1: Billing Charges - the single biggest, lowest-scoring driver, concentrated and compounding with “Sub-theme: Charged” in 72% of its own complaints.</a:t>
             </a:r>
           </a:p>
           <a:p>

</xml_diff>

<commit_message>
Drop survey_type, expand plan_tier to 5 options and circle to all 23 states
survey_type wasn't the right column per feedback - removed entirely.
plan_tier is now a flat 5-value list (Basic/Standard/Plus/Premium/Elite)
shared across LoBs instead of 2 LoB-tied options. circle now covers all
23 official Indian telecom circles (DoT-licensed service areas), which
collectively map to every state/UT, instead of an arbitrary 5-state list.

Updated summary/chart sections (15 charts now), PPT deck, narration
numbers, and CLAUDE.md's decision log to match. Regenerated end-to-end.
</commit_message>
<xml_diff>
--- a/usecase1_csat_nlp_rootcause/final_output/usecase1_csat_summary.pptx
+++ b/usecase1_csat_nlp_rootcause/final_output/usecase1_csat_summary.pptx
@@ -3738,7 +3738,7 @@
                 </a:solidFill>
                 <a:latin typeface="Calibri"/>
               </a:rPr>
-              <a:t>Channel mix:  Voice: 3,350  |  Chat: 2,642  |  Email: 1,508</a:t>
+              <a:t>Channel mix:  Voice: 3,322  |  Chat: 2,665  |  Email: 1,513</a:t>
             </a:r>
           </a:p>
         </p:txBody>
@@ -4447,7 +4447,7 @@
                 </a:solidFill>
                 <a:latin typeface="Calibri"/>
               </a:rPr>
-              <a:t>2.96</a:t>
+              <a:t>2.83</a:t>
             </a:r>
           </a:p>
           <a:p>
@@ -4459,7 +4459,7 @@
                 </a:solidFill>
                 <a:latin typeface="Calibri"/>
               </a:rPr>
-              <a:t>Lowest avg CSAT: Delhi NCR circle</a:t>
+              <a:t>Lowest avg CSAT: Mumbai circle</a:t>
             </a:r>
           </a:p>
         </p:txBody>
@@ -4514,7 +4514,7 @@
                 </a:solidFill>
                 <a:latin typeface="Calibri"/>
               </a:rPr>
-              <a:t>●   Delhi NCR is the lowest-performing circle (avg CSAT 2.96) and Postpaid Standard the lowest-performing plan tier (avg CSAT 2.90) - two segment-level leads worth investigating alongside the process fix.</a:t>
+              <a:t>●   Mumbai is the lowest-performing circle (avg CSAT 2.83) and Standard the lowest-performing plan tier (avg CSAT 2.98) - two segment-level leads worth investigating alongside the process fix.</a:t>
             </a:r>
           </a:p>
           <a:p>
@@ -4530,7 +4530,7 @@
                 </a:solidFill>
                 <a:latin typeface="Calibri"/>
               </a:rPr>
-              <a:t>●   CSAT mix: 38% Promoters (4-5) vs 38% Detractors (1-2) - a split, not a crisis, but with a specific, fixable lever.</a:t>
+              <a:t>●   CSAT mix: 39% Promoters (4-5) vs 38% Detractors (1-2) - a split, not a crisis, but with a specific, fixable lever.</a:t>
             </a:r>
           </a:p>
           <a:p>
@@ -4681,7 +4681,7 @@
                 </a:solidFill>
                 <a:latin typeface="Calibri"/>
               </a:rPr>
-              <a:t>●   Fix #1: Billing Charges - the single biggest, lowest-scoring driver, concentrated and compounding with “Sub-theme: Charged” in 72% of its own complaints.</a:t>
+              <a:t>●   Fix #1: Billing Charges - the single biggest, lowest-scoring driver, concentrated and compounding with “Sub-theme: Charged” in 45% of its own complaints.</a:t>
             </a:r>
           </a:p>
           <a:p>

</xml_diff>

<commit_message>
Fix agent_name realism: no index suffix, no repeated name parts across the roster
build_agent_roster() appended a "(i+1)" index to every agent_name purely
to dodge collisions in a small 20x10 first/last name grid - that index
leaked into the actual data column, which a real agent-name field would
never carry. Expanded both name pools to 30 entries each and sample first
and last names independently without replacement, so every one of the 24
agents gets a genuinely unique first name AND unique last name, not just
a unique full-name combination. Regenerated input/intermediate/final
output and updated narration_script.md's quoted numbers to match the new
(expected) random-sequence drift.
</commit_message>
<xml_diff>
--- a/usecase1_csat_nlp_rootcause/final_output/usecase1_csat_summary.pptx
+++ b/usecase1_csat_nlp_rootcause/final_output/usecase1_csat_summary.pptx
@@ -4908,7 +4908,7 @@
         <p:spPr>
           <a:xfrm>
             <a:off x="594360" y="4800600"/>
-            <a:ext cx="4934334" cy="411480"/>
+            <a:ext cx="4929981" cy="411480"/>
           </a:xfrm>
           <a:prstGeom prst="rect">
             <a:avLst/>
@@ -4953,8 +4953,8 @@
         </p:nvSpPr>
         <p:spPr>
           <a:xfrm>
-            <a:off x="5528694" y="4800600"/>
-            <a:ext cx="3762048" cy="411480"/>
+            <a:off x="5524341" y="4800600"/>
+            <a:ext cx="3773655" cy="411480"/>
           </a:xfrm>
           <a:prstGeom prst="rect">
             <a:avLst/>
@@ -4999,8 +4999,8 @@
         </p:nvSpPr>
         <p:spPr>
           <a:xfrm>
-            <a:off x="9290742" y="4800600"/>
-            <a:ext cx="2184977" cy="411480"/>
+            <a:off x="9297996" y="4800600"/>
+            <a:ext cx="2177722" cy="411480"/>
           </a:xfrm>
           <a:prstGeom prst="rect">
             <a:avLst/>
@@ -6590,7 +6590,7 @@
                 </a:solidFill>
                 <a:latin typeface="Calibri"/>
               </a:rPr>
-              <a:t>2.85</a:t>
+              <a:t>2.86</a:t>
             </a:r>
           </a:p>
           <a:p>
@@ -6701,7 +6701,7 @@
                 </a:solidFill>
                 <a:latin typeface="Calibri"/>
               </a:rPr>
-              <a:t>37%</a:t>
+              <a:t>38%</a:t>
             </a:r>
           </a:p>
           <a:p>
@@ -6873,7 +6873,7 @@
         <p:spPr>
           <a:xfrm>
             <a:off x="594360" y="3429000"/>
-            <a:ext cx="1676838" cy="411480"/>
+            <a:ext cx="1681618" cy="411480"/>
           </a:xfrm>
           <a:prstGeom prst="rect">
             <a:avLst/>
@@ -6918,8 +6918,8 @@
         </p:nvSpPr>
         <p:spPr>
           <a:xfrm>
-            <a:off x="2271198" y="3429000"/>
-            <a:ext cx="1314980" cy="411480"/>
+            <a:off x="2275978" y="3429000"/>
+            <a:ext cx="1313614" cy="411480"/>
           </a:xfrm>
           <a:prstGeom prst="rect">
             <a:avLst/>
@@ -6964,8 +6964,8 @@
         </p:nvSpPr>
         <p:spPr>
           <a:xfrm>
-            <a:off x="3586178" y="3429000"/>
-            <a:ext cx="2128820" cy="411480"/>
+            <a:off x="3589592" y="3429000"/>
+            <a:ext cx="2125406" cy="411480"/>
           </a:xfrm>
           <a:prstGeom prst="rect">
             <a:avLst/>
@@ -7392,7 +7392,7 @@
                 </a:solidFill>
                 <a:latin typeface="Calibri"/>
               </a:rPr>
-              <a:t>North East circle and Standard tier are the lowest-performing segments (avg CSAT 2.78 / 2.83).</a:t>
+              <a:t>North East circle and Elite tier are the lowest-performing segments (avg CSAT 2.78 / 2.82).</a:t>
             </a:r>
           </a:p>
         </p:txBody>
@@ -7705,7 +7705,7 @@
                 </a:solidFill>
                 <a:latin typeface="Calibri"/>
               </a:rPr>
-              <a:t>The single biggest, lowest-scoring driver, concentrated and compounding with “Duplicate Charge” in 21% of its own complaints.</a:t>
+              <a:t>The single biggest, lowest-scoring driver, concentrated and compounding with “Duplicate Charge” in 22% of its own complaints.</a:t>
             </a:r>
           </a:p>
         </p:txBody>

</xml_diff>